<commit_message>
feat: hoan thien pipeline tien xu ly, featuring, 5 mo hinh ML, truc quan hoa, logging, docker va render deployment
</commit_message>
<xml_diff>
--- a/docs/slides/BAO_CAO_Y_TUONG_DE_TAI.pptx
+++ b/docs/slides/BAO_CAO_Y_TUONG_DE_TAI.pptx
@@ -3305,7 +3305,7 @@
         <p:spPr>
           <a:xfrm>
             <a:off x="1188720" y="3657600"/>
-            <a:ext cx="9814255" cy="2194560"/>
+            <a:ext cx="9814255" cy="1138773"/>
           </a:xfrm>
           <a:prstGeom prst="rect">
             <a:avLst/>
@@ -3319,7 +3319,7 @@
           <a:lstStyle/>
           <a:p>
             <a:r>
-              <a:rPr sz="1300" b="1">
+              <a:rPr sz="1300" b="1" dirty="0">
                 <a:solidFill>
                   <a:srgbClr val="06B6D4"/>
                 </a:solidFill>
@@ -3330,57 +3330,792 @@
           </a:p>
           <a:p>
             <a:r>
-              <a:rPr sz="1100">
+              <a:rPr sz="1100" dirty="0">
                 <a:solidFill>
                   <a:srgbClr val="F8FAFC"/>
                 </a:solidFill>
                 <a:latin typeface="Segoe UI"/>
               </a:rPr>
-              <a:t>• 1. Hải Nam (Nhóm trưởng) — Kiến trúc hệ thống, Điều phối &amp; Báo cáo</a:t>
-            </a:r>
-          </a:p>
-          <a:p>
-            <a:r>
-              <a:rPr sz="1100">
+              <a:t>• 1. Hải Nam (</a:t>
+            </a:r>
+            <a:r>
+              <a:rPr lang="en-US" sz="1100" dirty="0">
                 <a:solidFill>
                   <a:srgbClr val="F8FAFC"/>
                 </a:solidFill>
                 <a:latin typeface="Segoe UI"/>
               </a:rPr>
-              <a:t>• 2. Bùi Mai Hân (202400041) — Tiền xử lý dữ liệu (Preprocessing) &amp; Phân tích khám phá (EDA)</a:t>
-            </a:r>
-          </a:p>
-          <a:p>
-            <a:r>
-              <a:rPr sz="1100">
+              <a:t>20251698</a:t>
+            </a:r>
+            <a:r>
+              <a:rPr sz="1100" dirty="0">
                 <a:solidFill>
                   <a:srgbClr val="F8FAFC"/>
                 </a:solidFill>
                 <a:latin typeface="Segoe UI"/>
               </a:rPr>
-              <a:t>• 3. Vũ Đình Khôi (20235124) — Trích xuất đặc trưng TF-IDF &amp; Mô hình Tuyến tính (Linear Models)</a:t>
-            </a:r>
-          </a:p>
-          <a:p>
-            <a:r>
-              <a:rPr sz="1100">
+              <a:t>) — </a:t>
+            </a:r>
+            <a:r>
+              <a:rPr sz="1100" dirty="0" err="1">
                 <a:solidFill>
                   <a:srgbClr val="F8FAFC"/>
                 </a:solidFill>
                 <a:latin typeface="Segoe UI"/>
               </a:rPr>
-              <a:t>• 4. Vũ Trung Kiên (202416253) — Thực nghiệm Mô hình Cây quyết định &amp; Ensemble (Tree-based Models)</a:t>
-            </a:r>
-          </a:p>
-          <a:p>
-            <a:r>
-              <a:rPr sz="1100">
+              <a:t>Kiến</a:t>
+            </a:r>
+            <a:r>
+              <a:rPr sz="1100" dirty="0">
                 <a:solidFill>
                   <a:srgbClr val="F8FAFC"/>
                 </a:solidFill>
                 <a:latin typeface="Segoe UI"/>
               </a:rPr>
-              <a:t>• 5. Nguyễn Hoàng Anh (202416121) — Đánh giá mô hình (Evaluation), Benchmark &amp; Phân tích lỗi (Error Analysis)</a:t>
+              <a:t> </a:t>
+            </a:r>
+            <a:r>
+              <a:rPr sz="1100" dirty="0" err="1">
+                <a:solidFill>
+                  <a:srgbClr val="F8FAFC"/>
+                </a:solidFill>
+                <a:latin typeface="Segoe UI"/>
+              </a:rPr>
+              <a:t>trúc</a:t>
+            </a:r>
+            <a:r>
+              <a:rPr sz="1100" dirty="0">
+                <a:solidFill>
+                  <a:srgbClr val="F8FAFC"/>
+                </a:solidFill>
+                <a:latin typeface="Segoe UI"/>
+              </a:rPr>
+              <a:t> </a:t>
+            </a:r>
+            <a:r>
+              <a:rPr sz="1100" dirty="0" err="1">
+                <a:solidFill>
+                  <a:srgbClr val="F8FAFC"/>
+                </a:solidFill>
+                <a:latin typeface="Segoe UI"/>
+              </a:rPr>
+              <a:t>hệ</a:t>
+            </a:r>
+            <a:r>
+              <a:rPr sz="1100" dirty="0">
+                <a:solidFill>
+                  <a:srgbClr val="F8FAFC"/>
+                </a:solidFill>
+                <a:latin typeface="Segoe UI"/>
+              </a:rPr>
+              <a:t> </a:t>
+            </a:r>
+            <a:r>
+              <a:rPr sz="1100" dirty="0" err="1">
+                <a:solidFill>
+                  <a:srgbClr val="F8FAFC"/>
+                </a:solidFill>
+                <a:latin typeface="Segoe UI"/>
+              </a:rPr>
+              <a:t>thống</a:t>
+            </a:r>
+            <a:r>
+              <a:rPr sz="1100" dirty="0">
+                <a:solidFill>
+                  <a:srgbClr val="F8FAFC"/>
+                </a:solidFill>
+                <a:latin typeface="Segoe UI"/>
+              </a:rPr>
+              <a:t>, </a:t>
+            </a:r>
+            <a:r>
+              <a:rPr sz="1100" dirty="0" err="1">
+                <a:solidFill>
+                  <a:srgbClr val="F8FAFC"/>
+                </a:solidFill>
+                <a:latin typeface="Segoe UI"/>
+              </a:rPr>
+              <a:t>Điều</a:t>
+            </a:r>
+            <a:r>
+              <a:rPr sz="1100" dirty="0">
+                <a:solidFill>
+                  <a:srgbClr val="F8FAFC"/>
+                </a:solidFill>
+                <a:latin typeface="Segoe UI"/>
+              </a:rPr>
+              <a:t> </a:t>
+            </a:r>
+            <a:r>
+              <a:rPr sz="1100" dirty="0" err="1">
+                <a:solidFill>
+                  <a:srgbClr val="F8FAFC"/>
+                </a:solidFill>
+                <a:latin typeface="Segoe UI"/>
+              </a:rPr>
+              <a:t>phối</a:t>
+            </a:r>
+            <a:r>
+              <a:rPr sz="1100" dirty="0">
+                <a:solidFill>
+                  <a:srgbClr val="F8FAFC"/>
+                </a:solidFill>
+                <a:latin typeface="Segoe UI"/>
+              </a:rPr>
+              <a:t> &amp; Báo </a:t>
+            </a:r>
+            <a:r>
+              <a:rPr sz="1100" dirty="0" err="1">
+                <a:solidFill>
+                  <a:srgbClr val="F8FAFC"/>
+                </a:solidFill>
+                <a:latin typeface="Segoe UI"/>
+              </a:rPr>
+              <a:t>cáo</a:t>
+            </a:r>
+            <a:endParaRPr sz="1100" dirty="0">
+              <a:solidFill>
+                <a:srgbClr val="F8FAFC"/>
+              </a:solidFill>
+              <a:latin typeface="Segoe UI"/>
+            </a:endParaRPr>
+          </a:p>
+          <a:p>
+            <a:r>
+              <a:rPr sz="1100" dirty="0">
+                <a:solidFill>
+                  <a:srgbClr val="F8FAFC"/>
+                </a:solidFill>
+                <a:latin typeface="Segoe UI"/>
+              </a:rPr>
+              <a:t>• 2. Bùi Mai </a:t>
+            </a:r>
+            <a:r>
+              <a:rPr sz="1100" dirty="0" err="1">
+                <a:solidFill>
+                  <a:srgbClr val="F8FAFC"/>
+                </a:solidFill>
+                <a:latin typeface="Segoe UI"/>
+              </a:rPr>
+              <a:t>Hân</a:t>
+            </a:r>
+            <a:r>
+              <a:rPr sz="1100" dirty="0">
+                <a:solidFill>
+                  <a:srgbClr val="F8FAFC"/>
+                </a:solidFill>
+                <a:latin typeface="Segoe UI"/>
+              </a:rPr>
+              <a:t> (202400041) — </a:t>
+            </a:r>
+            <a:r>
+              <a:rPr sz="1100" dirty="0" err="1">
+                <a:solidFill>
+                  <a:srgbClr val="F8FAFC"/>
+                </a:solidFill>
+                <a:latin typeface="Segoe UI"/>
+              </a:rPr>
+              <a:t>Tiền</a:t>
+            </a:r>
+            <a:r>
+              <a:rPr sz="1100" dirty="0">
+                <a:solidFill>
+                  <a:srgbClr val="F8FAFC"/>
+                </a:solidFill>
+                <a:latin typeface="Segoe UI"/>
+              </a:rPr>
+              <a:t> </a:t>
+            </a:r>
+            <a:r>
+              <a:rPr sz="1100" dirty="0" err="1">
+                <a:solidFill>
+                  <a:srgbClr val="F8FAFC"/>
+                </a:solidFill>
+                <a:latin typeface="Segoe UI"/>
+              </a:rPr>
+              <a:t>xử</a:t>
+            </a:r>
+            <a:r>
+              <a:rPr sz="1100" dirty="0">
+                <a:solidFill>
+                  <a:srgbClr val="F8FAFC"/>
+                </a:solidFill>
+                <a:latin typeface="Segoe UI"/>
+              </a:rPr>
+              <a:t> </a:t>
+            </a:r>
+            <a:r>
+              <a:rPr sz="1100" dirty="0" err="1">
+                <a:solidFill>
+                  <a:srgbClr val="F8FAFC"/>
+                </a:solidFill>
+                <a:latin typeface="Segoe UI"/>
+              </a:rPr>
+              <a:t>lý</a:t>
+            </a:r>
+            <a:r>
+              <a:rPr sz="1100" dirty="0">
+                <a:solidFill>
+                  <a:srgbClr val="F8FAFC"/>
+                </a:solidFill>
+                <a:latin typeface="Segoe UI"/>
+              </a:rPr>
+              <a:t> </a:t>
+            </a:r>
+            <a:r>
+              <a:rPr sz="1100" dirty="0" err="1">
+                <a:solidFill>
+                  <a:srgbClr val="F8FAFC"/>
+                </a:solidFill>
+                <a:latin typeface="Segoe UI"/>
+              </a:rPr>
+              <a:t>dữ</a:t>
+            </a:r>
+            <a:r>
+              <a:rPr sz="1100" dirty="0">
+                <a:solidFill>
+                  <a:srgbClr val="F8FAFC"/>
+                </a:solidFill>
+                <a:latin typeface="Segoe UI"/>
+              </a:rPr>
+              <a:t> </a:t>
+            </a:r>
+            <a:r>
+              <a:rPr sz="1100" dirty="0" err="1">
+                <a:solidFill>
+                  <a:srgbClr val="F8FAFC"/>
+                </a:solidFill>
+                <a:latin typeface="Segoe UI"/>
+              </a:rPr>
+              <a:t>liệu</a:t>
+            </a:r>
+            <a:r>
+              <a:rPr sz="1100" dirty="0">
+                <a:solidFill>
+                  <a:srgbClr val="F8FAFC"/>
+                </a:solidFill>
+                <a:latin typeface="Segoe UI"/>
+              </a:rPr>
+              <a:t> (Preprocessing) &amp; </a:t>
+            </a:r>
+            <a:r>
+              <a:rPr sz="1100" dirty="0" err="1">
+                <a:solidFill>
+                  <a:srgbClr val="F8FAFC"/>
+                </a:solidFill>
+                <a:latin typeface="Segoe UI"/>
+              </a:rPr>
+              <a:t>Phân</a:t>
+            </a:r>
+            <a:r>
+              <a:rPr sz="1100" dirty="0">
+                <a:solidFill>
+                  <a:srgbClr val="F8FAFC"/>
+                </a:solidFill>
+                <a:latin typeface="Segoe UI"/>
+              </a:rPr>
+              <a:t> </a:t>
+            </a:r>
+            <a:r>
+              <a:rPr sz="1100" dirty="0" err="1">
+                <a:solidFill>
+                  <a:srgbClr val="F8FAFC"/>
+                </a:solidFill>
+                <a:latin typeface="Segoe UI"/>
+              </a:rPr>
+              <a:t>tích</a:t>
+            </a:r>
+            <a:r>
+              <a:rPr sz="1100" dirty="0">
+                <a:solidFill>
+                  <a:srgbClr val="F8FAFC"/>
+                </a:solidFill>
+                <a:latin typeface="Segoe UI"/>
+              </a:rPr>
+              <a:t> </a:t>
+            </a:r>
+            <a:r>
+              <a:rPr sz="1100" dirty="0" err="1">
+                <a:solidFill>
+                  <a:srgbClr val="F8FAFC"/>
+                </a:solidFill>
+                <a:latin typeface="Segoe UI"/>
+              </a:rPr>
+              <a:t>khám</a:t>
+            </a:r>
+            <a:r>
+              <a:rPr sz="1100" dirty="0">
+                <a:solidFill>
+                  <a:srgbClr val="F8FAFC"/>
+                </a:solidFill>
+                <a:latin typeface="Segoe UI"/>
+              </a:rPr>
+              <a:t> </a:t>
+            </a:r>
+            <a:r>
+              <a:rPr sz="1100" dirty="0" err="1">
+                <a:solidFill>
+                  <a:srgbClr val="F8FAFC"/>
+                </a:solidFill>
+                <a:latin typeface="Segoe UI"/>
+              </a:rPr>
+              <a:t>phá</a:t>
+            </a:r>
+            <a:r>
+              <a:rPr sz="1100" dirty="0">
+                <a:solidFill>
+                  <a:srgbClr val="F8FAFC"/>
+                </a:solidFill>
+                <a:latin typeface="Segoe UI"/>
+              </a:rPr>
+              <a:t> (EDA)</a:t>
+            </a:r>
+          </a:p>
+          <a:p>
+            <a:r>
+              <a:rPr sz="1100" dirty="0">
+                <a:solidFill>
+                  <a:srgbClr val="F8FAFC"/>
+                </a:solidFill>
+                <a:latin typeface="Segoe UI"/>
+              </a:rPr>
+              <a:t>• 3. Vũ </a:t>
+            </a:r>
+            <a:r>
+              <a:rPr sz="1100" dirty="0" err="1">
+                <a:solidFill>
+                  <a:srgbClr val="F8FAFC"/>
+                </a:solidFill>
+                <a:latin typeface="Segoe UI"/>
+              </a:rPr>
+              <a:t>Đình</a:t>
+            </a:r>
+            <a:r>
+              <a:rPr sz="1100" dirty="0">
+                <a:solidFill>
+                  <a:srgbClr val="F8FAFC"/>
+                </a:solidFill>
+                <a:latin typeface="Segoe UI"/>
+              </a:rPr>
+              <a:t> </a:t>
+            </a:r>
+            <a:r>
+              <a:rPr sz="1100" dirty="0" err="1">
+                <a:solidFill>
+                  <a:srgbClr val="F8FAFC"/>
+                </a:solidFill>
+                <a:latin typeface="Segoe UI"/>
+              </a:rPr>
+              <a:t>Khôi</a:t>
+            </a:r>
+            <a:r>
+              <a:rPr sz="1100" dirty="0">
+                <a:solidFill>
+                  <a:srgbClr val="F8FAFC"/>
+                </a:solidFill>
+                <a:latin typeface="Segoe UI"/>
+              </a:rPr>
+              <a:t> (20235124) — </a:t>
+            </a:r>
+            <a:r>
+              <a:rPr sz="1100" dirty="0" err="1">
+                <a:solidFill>
+                  <a:srgbClr val="F8FAFC"/>
+                </a:solidFill>
+                <a:latin typeface="Segoe UI"/>
+              </a:rPr>
+              <a:t>Trích</a:t>
+            </a:r>
+            <a:r>
+              <a:rPr sz="1100" dirty="0">
+                <a:solidFill>
+                  <a:srgbClr val="F8FAFC"/>
+                </a:solidFill>
+                <a:latin typeface="Segoe UI"/>
+              </a:rPr>
+              <a:t> </a:t>
+            </a:r>
+            <a:r>
+              <a:rPr sz="1100" dirty="0" err="1">
+                <a:solidFill>
+                  <a:srgbClr val="F8FAFC"/>
+                </a:solidFill>
+                <a:latin typeface="Segoe UI"/>
+              </a:rPr>
+              <a:t>xuất</a:t>
+            </a:r>
+            <a:r>
+              <a:rPr sz="1100" dirty="0">
+                <a:solidFill>
+                  <a:srgbClr val="F8FAFC"/>
+                </a:solidFill>
+                <a:latin typeface="Segoe UI"/>
+              </a:rPr>
+              <a:t> </a:t>
+            </a:r>
+            <a:r>
+              <a:rPr sz="1100" dirty="0" err="1">
+                <a:solidFill>
+                  <a:srgbClr val="F8FAFC"/>
+                </a:solidFill>
+                <a:latin typeface="Segoe UI"/>
+              </a:rPr>
+              <a:t>đặc</a:t>
+            </a:r>
+            <a:r>
+              <a:rPr sz="1100" dirty="0">
+                <a:solidFill>
+                  <a:srgbClr val="F8FAFC"/>
+                </a:solidFill>
+                <a:latin typeface="Segoe UI"/>
+              </a:rPr>
+              <a:t> </a:t>
+            </a:r>
+            <a:r>
+              <a:rPr sz="1100" dirty="0" err="1">
+                <a:solidFill>
+                  <a:srgbClr val="F8FAFC"/>
+                </a:solidFill>
+                <a:latin typeface="Segoe UI"/>
+              </a:rPr>
+              <a:t>trưng</a:t>
+            </a:r>
+            <a:r>
+              <a:rPr sz="1100" dirty="0">
+                <a:solidFill>
+                  <a:srgbClr val="F8FAFC"/>
+                </a:solidFill>
+                <a:latin typeface="Segoe UI"/>
+              </a:rPr>
+              <a:t> TF-IDF &amp; </a:t>
+            </a:r>
+            <a:r>
+              <a:rPr sz="1100" dirty="0" err="1">
+                <a:solidFill>
+                  <a:srgbClr val="F8FAFC"/>
+                </a:solidFill>
+                <a:latin typeface="Segoe UI"/>
+              </a:rPr>
+              <a:t>Mô</a:t>
+            </a:r>
+            <a:r>
+              <a:rPr sz="1100" dirty="0">
+                <a:solidFill>
+                  <a:srgbClr val="F8FAFC"/>
+                </a:solidFill>
+                <a:latin typeface="Segoe UI"/>
+              </a:rPr>
+              <a:t> </a:t>
+            </a:r>
+            <a:r>
+              <a:rPr sz="1100" dirty="0" err="1">
+                <a:solidFill>
+                  <a:srgbClr val="F8FAFC"/>
+                </a:solidFill>
+                <a:latin typeface="Segoe UI"/>
+              </a:rPr>
+              <a:t>hình</a:t>
+            </a:r>
+            <a:r>
+              <a:rPr sz="1100" dirty="0">
+                <a:solidFill>
+                  <a:srgbClr val="F8FAFC"/>
+                </a:solidFill>
+                <a:latin typeface="Segoe UI"/>
+              </a:rPr>
+              <a:t> Tuyến </a:t>
+            </a:r>
+            <a:r>
+              <a:rPr sz="1100" dirty="0" err="1">
+                <a:solidFill>
+                  <a:srgbClr val="F8FAFC"/>
+                </a:solidFill>
+                <a:latin typeface="Segoe UI"/>
+              </a:rPr>
+              <a:t>tính</a:t>
+            </a:r>
+            <a:r>
+              <a:rPr sz="1100" dirty="0">
+                <a:solidFill>
+                  <a:srgbClr val="F8FAFC"/>
+                </a:solidFill>
+                <a:latin typeface="Segoe UI"/>
+              </a:rPr>
+              <a:t> (Linear Models)</a:t>
+            </a:r>
+          </a:p>
+          <a:p>
+            <a:r>
+              <a:rPr sz="1100" dirty="0">
+                <a:solidFill>
+                  <a:srgbClr val="F8FAFC"/>
+                </a:solidFill>
+                <a:latin typeface="Segoe UI"/>
+              </a:rPr>
+              <a:t>• 4. Vũ Trung Kiên (202416253) — </a:t>
+            </a:r>
+            <a:r>
+              <a:rPr sz="1100" dirty="0" err="1">
+                <a:solidFill>
+                  <a:srgbClr val="F8FAFC"/>
+                </a:solidFill>
+                <a:latin typeface="Segoe UI"/>
+              </a:rPr>
+              <a:t>Thực</a:t>
+            </a:r>
+            <a:r>
+              <a:rPr sz="1100" dirty="0">
+                <a:solidFill>
+                  <a:srgbClr val="F8FAFC"/>
+                </a:solidFill>
+                <a:latin typeface="Segoe UI"/>
+              </a:rPr>
+              <a:t> </a:t>
+            </a:r>
+            <a:r>
+              <a:rPr sz="1100" dirty="0" err="1">
+                <a:solidFill>
+                  <a:srgbClr val="F8FAFC"/>
+                </a:solidFill>
+                <a:latin typeface="Segoe UI"/>
+              </a:rPr>
+              <a:t>nghiệm</a:t>
+            </a:r>
+            <a:r>
+              <a:rPr sz="1100" dirty="0">
+                <a:solidFill>
+                  <a:srgbClr val="F8FAFC"/>
+                </a:solidFill>
+                <a:latin typeface="Segoe UI"/>
+              </a:rPr>
+              <a:t> </a:t>
+            </a:r>
+            <a:r>
+              <a:rPr sz="1100" dirty="0" err="1">
+                <a:solidFill>
+                  <a:srgbClr val="F8FAFC"/>
+                </a:solidFill>
+                <a:latin typeface="Segoe UI"/>
+              </a:rPr>
+              <a:t>Mô</a:t>
+            </a:r>
+            <a:r>
+              <a:rPr sz="1100" dirty="0">
+                <a:solidFill>
+                  <a:srgbClr val="F8FAFC"/>
+                </a:solidFill>
+                <a:latin typeface="Segoe UI"/>
+              </a:rPr>
+              <a:t> </a:t>
+            </a:r>
+            <a:r>
+              <a:rPr sz="1100" dirty="0" err="1">
+                <a:solidFill>
+                  <a:srgbClr val="F8FAFC"/>
+                </a:solidFill>
+                <a:latin typeface="Segoe UI"/>
+              </a:rPr>
+              <a:t>hình</a:t>
+            </a:r>
+            <a:r>
+              <a:rPr sz="1100" dirty="0">
+                <a:solidFill>
+                  <a:srgbClr val="F8FAFC"/>
+                </a:solidFill>
+                <a:latin typeface="Segoe UI"/>
+              </a:rPr>
+              <a:t> </a:t>
+            </a:r>
+            <a:r>
+              <a:rPr sz="1100" dirty="0" err="1">
+                <a:solidFill>
+                  <a:srgbClr val="F8FAFC"/>
+                </a:solidFill>
+                <a:latin typeface="Segoe UI"/>
+              </a:rPr>
+              <a:t>Cây</a:t>
+            </a:r>
+            <a:r>
+              <a:rPr sz="1100" dirty="0">
+                <a:solidFill>
+                  <a:srgbClr val="F8FAFC"/>
+                </a:solidFill>
+                <a:latin typeface="Segoe UI"/>
+              </a:rPr>
+              <a:t> </a:t>
+            </a:r>
+            <a:r>
+              <a:rPr sz="1100" dirty="0" err="1">
+                <a:solidFill>
+                  <a:srgbClr val="F8FAFC"/>
+                </a:solidFill>
+                <a:latin typeface="Segoe UI"/>
+              </a:rPr>
+              <a:t>quyết</a:t>
+            </a:r>
+            <a:r>
+              <a:rPr sz="1100" dirty="0">
+                <a:solidFill>
+                  <a:srgbClr val="F8FAFC"/>
+                </a:solidFill>
+                <a:latin typeface="Segoe UI"/>
+              </a:rPr>
+              <a:t> </a:t>
+            </a:r>
+            <a:r>
+              <a:rPr sz="1100" dirty="0" err="1">
+                <a:solidFill>
+                  <a:srgbClr val="F8FAFC"/>
+                </a:solidFill>
+                <a:latin typeface="Segoe UI"/>
+              </a:rPr>
+              <a:t>định</a:t>
+            </a:r>
+            <a:r>
+              <a:rPr sz="1100" dirty="0">
+                <a:solidFill>
+                  <a:srgbClr val="F8FAFC"/>
+                </a:solidFill>
+                <a:latin typeface="Segoe UI"/>
+              </a:rPr>
+              <a:t> &amp; Ensemble (Tree-based Models)</a:t>
+            </a:r>
+          </a:p>
+          <a:p>
+            <a:r>
+              <a:rPr sz="1100" dirty="0">
+                <a:solidFill>
+                  <a:srgbClr val="F8FAFC"/>
+                </a:solidFill>
+                <a:latin typeface="Segoe UI"/>
+              </a:rPr>
+              <a:t>• 5. Nguyễn Hoàng Anh (202416121) — </a:t>
+            </a:r>
+            <a:r>
+              <a:rPr sz="1100" dirty="0" err="1">
+                <a:solidFill>
+                  <a:srgbClr val="F8FAFC"/>
+                </a:solidFill>
+                <a:latin typeface="Segoe UI"/>
+              </a:rPr>
+              <a:t>Đánh</a:t>
+            </a:r>
+            <a:r>
+              <a:rPr sz="1100" dirty="0">
+                <a:solidFill>
+                  <a:srgbClr val="F8FAFC"/>
+                </a:solidFill>
+                <a:latin typeface="Segoe UI"/>
+              </a:rPr>
+              <a:t> </a:t>
+            </a:r>
+            <a:r>
+              <a:rPr sz="1100" dirty="0" err="1">
+                <a:solidFill>
+                  <a:srgbClr val="F8FAFC"/>
+                </a:solidFill>
+                <a:latin typeface="Segoe UI"/>
+              </a:rPr>
+              <a:t>giá</a:t>
+            </a:r>
+            <a:r>
+              <a:rPr sz="1100" dirty="0">
+                <a:solidFill>
+                  <a:srgbClr val="F8FAFC"/>
+                </a:solidFill>
+                <a:latin typeface="Segoe UI"/>
+              </a:rPr>
+              <a:t> </a:t>
+            </a:r>
+            <a:r>
+              <a:rPr sz="1100" dirty="0" err="1">
+                <a:solidFill>
+                  <a:srgbClr val="F8FAFC"/>
+                </a:solidFill>
+                <a:latin typeface="Segoe UI"/>
+              </a:rPr>
+              <a:t>mô</a:t>
+            </a:r>
+            <a:r>
+              <a:rPr sz="1100" dirty="0">
+                <a:solidFill>
+                  <a:srgbClr val="F8FAFC"/>
+                </a:solidFill>
+                <a:latin typeface="Segoe UI"/>
+              </a:rPr>
+              <a:t> </a:t>
+            </a:r>
+            <a:r>
+              <a:rPr sz="1100" dirty="0" err="1">
+                <a:solidFill>
+                  <a:srgbClr val="F8FAFC"/>
+                </a:solidFill>
+                <a:latin typeface="Segoe UI"/>
+              </a:rPr>
+              <a:t>hình</a:t>
+            </a:r>
+            <a:r>
+              <a:rPr sz="1100" dirty="0">
+                <a:solidFill>
+                  <a:srgbClr val="F8FAFC"/>
+                </a:solidFill>
+                <a:latin typeface="Segoe UI"/>
+              </a:rPr>
+              <a:t> (Evaluation), Benchmark &amp; </a:t>
+            </a:r>
+            <a:r>
+              <a:rPr sz="1100" dirty="0" err="1">
+                <a:solidFill>
+                  <a:srgbClr val="F8FAFC"/>
+                </a:solidFill>
+                <a:latin typeface="Segoe UI"/>
+              </a:rPr>
+              <a:t>Phân</a:t>
+            </a:r>
+            <a:r>
+              <a:rPr sz="1100" dirty="0">
+                <a:solidFill>
+                  <a:srgbClr val="F8FAFC"/>
+                </a:solidFill>
+                <a:latin typeface="Segoe UI"/>
+              </a:rPr>
+              <a:t> </a:t>
+            </a:r>
+            <a:r>
+              <a:rPr sz="1100" dirty="0" err="1">
+                <a:solidFill>
+                  <a:srgbClr val="F8FAFC"/>
+                </a:solidFill>
+                <a:latin typeface="Segoe UI"/>
+              </a:rPr>
+              <a:t>tích</a:t>
+            </a:r>
+            <a:r>
+              <a:rPr sz="1100" dirty="0">
+                <a:solidFill>
+                  <a:srgbClr val="F8FAFC"/>
+                </a:solidFill>
+                <a:latin typeface="Segoe UI"/>
+              </a:rPr>
+              <a:t> </a:t>
+            </a:r>
+            <a:r>
+              <a:rPr sz="1100" dirty="0" err="1">
+                <a:solidFill>
+                  <a:srgbClr val="F8FAFC"/>
+                </a:solidFill>
+                <a:latin typeface="Segoe UI"/>
+              </a:rPr>
+              <a:t>lỗi</a:t>
+            </a:r>
+            <a:r>
+              <a:rPr sz="1100" dirty="0">
+                <a:solidFill>
+                  <a:srgbClr val="F8FAFC"/>
+                </a:solidFill>
+                <a:latin typeface="Segoe UI"/>
+              </a:rPr>
+              <a:t> (Error Analysis)</a:t>
             </a:r>
           </a:p>
         </p:txBody>

</xml_diff>